<commit_message>
Remove Capgemini branding from architecture deck
Footer, document properties and theme name now read "Platform Observability".

Co-Authored-By: Claude Opus 5.5 <noreply@anthropic.com>
Claude-Session: https://claude.ai/code/session_016Gr3jEFQJ8YRUuWDkmh4cw
</commit_message>
<xml_diff>
--- a/docs/architecture/Snowflake_Query_Alerts_Architecture.pptx
+++ b/docs/architecture/Snowflake_Query_Alerts_Architecture.pptx
@@ -116,25 +116,25 @@
   <p:extLst>
     <p:ext uri="{521415D9-36F7-43E2-AB2F-B90AF26B5E84}">
       <p14:sectionLst xmlns:p14="http://schemas.microsoft.com/office/powerpoint/2010/main">
-        <p14:section name="Overview" id="{8499302d-1215-3111-68f2-3ac43152e275}">
+        <p14:section name="Overview" id="{a66c7ed4-6dba-4735-b73d-6df88b1eff1a}">
           <p14:sldIdLst>
             <p14:sldId id="256"/>
             <p14:sldId id="257"/>
           </p14:sldIdLst>
         </p14:section>
-        <p14:section name="Architecture" id="{93d3881e-9c56-30b0-d19e-148cac6620c0}">
+        <p14:section name="Architecture" id="{4c265088-e9d3-d49a-d3cd-01bd173695ec}">
           <p14:sldIdLst>
             <p14:sldId id="258"/>
             <p14:sldId id="259"/>
           </p14:sldIdLst>
         </p14:section>
-        <p14:section name="Channels" id="{e130d4b2-2143-54ab-9543-7aaa1caed5b0}">
+        <p14:section name="Channels" id="{f083f8cf-3ca4-345f-e942-a9f05a740c01}">
           <p14:sldIdLst>
             <p14:sldId id="260"/>
             <p14:sldId id="261"/>
           </p14:sldIdLst>
         </p14:section>
-        <p14:section name="Build and run" id="{2fc5cf73-fcf5-0bd6-1e46-43d7d3f1df3d}">
+        <p14:section name="Build and run" id="{e3ebbf38-778c-780c-cbb1-87de8b802720}">
           <p14:sldIdLst>
             <p14:sldId id="262"/>
             <p14:sldId id="263"/>
@@ -1551,7 +1551,7 @@
                 <a:ea typeface="Calibri" pitchFamily="34" charset="-122"/>
                 <a:cs typeface="Calibri" pitchFamily="34" charset="-120"/>
               </a:rPr>
-              <a:t>Capgemini  |  Platform Observability</a:t>
+              <a:t>Platform Observability</a:t>
             </a:r>
             <a:endParaRPr lang="en-US" sz="1100" dirty="0"/>
           </a:p>
@@ -15991,9 +15991,9 @@
 </file>
 
 <file path=ppt/theme/theme1.xml><?xml version="1.0" encoding="utf-8"?>
-<a:theme xmlns:a="http://schemas.openxmlformats.org/drawingml/2006/main" name="Capgemini Observability">
+<a:theme xmlns:a="http://schemas.openxmlformats.org/drawingml/2006/main" name="Platform Observability">
   <a:themeElements>
-    <a:clrScheme name="Capgemini Observability">
+    <a:clrScheme name="Platform Observability">
       <a:dk1>
         <a:srgbClr val="1F2A36"/>
       </a:dk1>
@@ -16031,7 +16031,7 @@
         <a:srgbClr val="003D5A"/>
       </a:folHlink>
     </a:clrScheme>
-    <a:fontScheme name="Capgemini Observability">
+    <a:fontScheme name="Platform Observability">
       <a:majorFont>
         <a:latin typeface="Cambria"/>
         <a:ea typeface=""/>

</xml_diff>